<commit_message>
Update The Human Blueprint presentation
</commit_message>
<xml_diff>
--- a/client/public/assets/The_Human_Blueprint.pptx
+++ b/client/public/assets/The_Human_Blueprint.pptx
@@ -4194,6 +4194,62 @@
           </a:p>
         </p:txBody>
       </p:sp>
+      <p:sp>
+        <p:nvSpPr>
+          <p:cNvPr id="8" name="Text 3">
+            <a:extLst>
+              <a:ext uri="{FF2B5EF4-FFF2-40B4-BE49-F238E27FC236}">
+                <a16:creationId xmlns:a16="http://schemas.microsoft.com/office/drawing/2014/main" id="{E1498D16-0DFE-BDED-FA0F-FE7579D06118}"/>
+              </a:ext>
+            </a:extLst>
+          </p:cNvPr>
+          <p:cNvSpPr/>
+          <p:nvPr/>
+        </p:nvSpPr>
+        <p:spPr>
+          <a:xfrm>
+            <a:off x="731520" y="4069080"/>
+            <a:ext cx="3567955" cy="457200"/>
+          </a:xfrm>
+          <a:prstGeom prst="rect">
+            <a:avLst/>
+          </a:prstGeom>
+          <a:noFill/>
+          <a:ln/>
+        </p:spPr>
+        <p:txBody>
+          <a:bodyPr wrap="square" rtlCol="0" anchor="ctr"/>
+          <a:lstStyle/>
+          <a:p>
+            <a:pPr marL="0" indent="0">
+              <a:buNone/>
+            </a:pPr>
+            <a:r>
+              <a:rPr lang="en-US" sz="1000" dirty="0">
+                <a:solidFill>
+                  <a:srgbClr val="67E8F9"/>
+                </a:solidFill>
+                <a:latin typeface="Calibri" pitchFamily="34" charset="0"/>
+                <a:ea typeface="Calibri" pitchFamily="34" charset="-122"/>
+                <a:cs typeface="Calibri" pitchFamily="34" charset="-120"/>
+              </a:rPr>
+              <a:t>https://human-</a:t>
+            </a:r>
+            <a:r>
+              <a:rPr lang="en-US" sz="1000" dirty="0" err="1">
+                <a:solidFill>
+                  <a:srgbClr val="67E8F9"/>
+                </a:solidFill>
+                <a:latin typeface="Calibri" pitchFamily="34" charset="0"/>
+                <a:ea typeface="Calibri" pitchFamily="34" charset="-122"/>
+                <a:cs typeface="Calibri" pitchFamily="34" charset="-120"/>
+              </a:rPr>
+              <a:t>blueprint.ai</a:t>
+            </a:r>
+            <a:endParaRPr lang="en-US" sz="1000" dirty="0"/>
+          </a:p>
+        </p:txBody>
+      </p:sp>
     </p:spTree>
   </p:cSld>
   <p:clrMapOvr>
@@ -4913,7 +4969,7 @@
         </p:nvSpPr>
         <p:spPr>
           <a:xfrm>
-            <a:off x="1554480" y="1938528"/>
+            <a:off x="1554480" y="2029968"/>
             <a:ext cx="1828800" cy="274320"/>
           </a:xfrm>
           <a:prstGeom prst="rect">
@@ -5057,7 +5113,7 @@
         </p:nvSpPr>
         <p:spPr>
           <a:xfrm>
-            <a:off x="1554480" y="2532888"/>
+            <a:off x="1554480" y="2619756"/>
             <a:ext cx="1828800" cy="274320"/>
           </a:xfrm>
           <a:prstGeom prst="rect">
@@ -5201,7 +5257,7 @@
         </p:nvSpPr>
         <p:spPr>
           <a:xfrm>
-            <a:off x="1554480" y="3127248"/>
+            <a:off x="1554480" y="3218688"/>
             <a:ext cx="1828800" cy="274320"/>
           </a:xfrm>
           <a:prstGeom prst="rect">
@@ -5345,7 +5401,7 @@
         </p:nvSpPr>
         <p:spPr>
           <a:xfrm>
-            <a:off x="1554480" y="3721608"/>
+            <a:off x="1554480" y="3808035"/>
             <a:ext cx="1828800" cy="274320"/>
           </a:xfrm>
           <a:prstGeom prst="rect">
@@ -5489,7 +5545,7 @@
         </p:nvSpPr>
         <p:spPr>
           <a:xfrm>
-            <a:off x="1554480" y="4315968"/>
+            <a:off x="1554480" y="4402395"/>
             <a:ext cx="1828800" cy="274320"/>
           </a:xfrm>
           <a:prstGeom prst="rect">
@@ -20474,7 +20530,7 @@
         </p:nvSpPr>
         <p:spPr>
           <a:xfrm>
-            <a:off x="731520" y="1051560"/>
+            <a:off x="731520" y="949442"/>
             <a:ext cx="7680960" cy="640080"/>
           </a:xfrm>
           <a:prstGeom prst="rect">
@@ -20508,7 +20564,7 @@
         </p:nvSpPr>
         <p:spPr>
           <a:xfrm>
-            <a:off x="731520" y="1051560"/>
+            <a:off x="731520" y="949442"/>
             <a:ext cx="54864" cy="640080"/>
           </a:xfrm>
           <a:prstGeom prst="rect">
@@ -20543,7 +20599,7 @@
         </p:blipFill>
         <p:spPr>
           <a:xfrm>
-            <a:off x="960120" y="1161288"/>
+            <a:off x="960120" y="1059170"/>
             <a:ext cx="365760" cy="365760"/>
           </a:xfrm>
           <a:prstGeom prst="rect">
@@ -20559,7 +20615,7 @@
         </p:nvSpPr>
         <p:spPr>
           <a:xfrm>
-            <a:off x="1463040" y="1097280"/>
+            <a:off x="1463040" y="995162"/>
             <a:ext cx="6309360" cy="320040"/>
           </a:xfrm>
           <a:prstGeom prst="rect">
@@ -20598,7 +20654,7 @@
         </p:nvSpPr>
         <p:spPr>
           <a:xfrm>
-            <a:off x="1463040" y="1371600"/>
+            <a:off x="1463040" y="1269482"/>
             <a:ext cx="6309360" cy="274320"/>
           </a:xfrm>
           <a:prstGeom prst="rect">
@@ -20637,7 +20693,7 @@
         </p:nvSpPr>
         <p:spPr>
           <a:xfrm>
-            <a:off x="914400" y="1828800"/>
+            <a:off x="914400" y="1726682"/>
             <a:ext cx="7315200" cy="640080"/>
           </a:xfrm>
           <a:prstGeom prst="rect">
@@ -20671,7 +20727,7 @@
         </p:nvSpPr>
         <p:spPr>
           <a:xfrm>
-            <a:off x="914400" y="1828800"/>
+            <a:off x="914400" y="1726682"/>
             <a:ext cx="54864" cy="640080"/>
           </a:xfrm>
           <a:prstGeom prst="rect">
@@ -20706,7 +20762,7 @@
         </p:blipFill>
         <p:spPr>
           <a:xfrm>
-            <a:off x="1143000" y="1938528"/>
+            <a:off x="1143000" y="1836410"/>
             <a:ext cx="365760" cy="365760"/>
           </a:xfrm>
           <a:prstGeom prst="rect">
@@ -20722,7 +20778,7 @@
         </p:nvSpPr>
         <p:spPr>
           <a:xfrm>
-            <a:off x="1645920" y="1874520"/>
+            <a:off x="1645920" y="1772402"/>
             <a:ext cx="5943600" cy="320040"/>
           </a:xfrm>
           <a:prstGeom prst="rect">
@@ -20761,7 +20817,7 @@
         </p:nvSpPr>
         <p:spPr>
           <a:xfrm>
-            <a:off x="1645920" y="2148840"/>
+            <a:off x="1645920" y="2046722"/>
             <a:ext cx="5943600" cy="274320"/>
           </a:xfrm>
           <a:prstGeom prst="rect">
@@ -20800,7 +20856,7 @@
         </p:nvSpPr>
         <p:spPr>
           <a:xfrm>
-            <a:off x="1097280" y="2606040"/>
+            <a:off x="1097280" y="2503922"/>
             <a:ext cx="6949440" cy="640080"/>
           </a:xfrm>
           <a:prstGeom prst="rect">
@@ -20834,7 +20890,7 @@
         </p:nvSpPr>
         <p:spPr>
           <a:xfrm>
-            <a:off x="1097280" y="2606040"/>
+            <a:off x="1097280" y="2503922"/>
             <a:ext cx="54864" cy="640080"/>
           </a:xfrm>
           <a:prstGeom prst="rect">
@@ -20869,7 +20925,7 @@
         </p:blipFill>
         <p:spPr>
           <a:xfrm>
-            <a:off x="1325880" y="2715768"/>
+            <a:off x="1325880" y="2613650"/>
             <a:ext cx="365760" cy="365760"/>
           </a:xfrm>
           <a:prstGeom prst="rect">
@@ -20885,7 +20941,7 @@
         </p:nvSpPr>
         <p:spPr>
           <a:xfrm>
-            <a:off x="1828800" y="2651760"/>
+            <a:off x="1828800" y="2549642"/>
             <a:ext cx="5577840" cy="320040"/>
           </a:xfrm>
           <a:prstGeom prst="rect">
@@ -20924,7 +20980,7 @@
         </p:nvSpPr>
         <p:spPr>
           <a:xfrm>
-            <a:off x="1828800" y="2926080"/>
+            <a:off x="1828800" y="2823962"/>
             <a:ext cx="5577840" cy="274320"/>
           </a:xfrm>
           <a:prstGeom prst="rect">
@@ -20963,7 +21019,7 @@
         </p:nvSpPr>
         <p:spPr>
           <a:xfrm>
-            <a:off x="1280160" y="3383280"/>
+            <a:off x="1280160" y="3281162"/>
             <a:ext cx="6583680" cy="640080"/>
           </a:xfrm>
           <a:prstGeom prst="rect">
@@ -20997,7 +21053,7 @@
         </p:nvSpPr>
         <p:spPr>
           <a:xfrm>
-            <a:off x="1280160" y="3383280"/>
+            <a:off x="1280160" y="3281162"/>
             <a:ext cx="54864" cy="640080"/>
           </a:xfrm>
           <a:prstGeom prst="rect">
@@ -21032,7 +21088,7 @@
         </p:blipFill>
         <p:spPr>
           <a:xfrm>
-            <a:off x="1508760" y="3493008"/>
+            <a:off x="1508760" y="3390890"/>
             <a:ext cx="365760" cy="365760"/>
           </a:xfrm>
           <a:prstGeom prst="rect">
@@ -21048,7 +21104,7 @@
         </p:nvSpPr>
         <p:spPr>
           <a:xfrm>
-            <a:off x="2011680" y="3429000"/>
+            <a:off x="2011680" y="3326882"/>
             <a:ext cx="5212080" cy="320040"/>
           </a:xfrm>
           <a:prstGeom prst="rect">
@@ -21087,7 +21143,7 @@
         </p:nvSpPr>
         <p:spPr>
           <a:xfrm>
-            <a:off x="2011680" y="3703320"/>
+            <a:off x="2011680" y="3601202"/>
             <a:ext cx="5212080" cy="274320"/>
           </a:xfrm>
           <a:prstGeom prst="rect">
@@ -21126,7 +21182,7 @@
         </p:nvSpPr>
         <p:spPr>
           <a:xfrm>
-            <a:off x="1463040" y="4160520"/>
+            <a:off x="1463040" y="4058402"/>
             <a:ext cx="6217920" cy="640080"/>
           </a:xfrm>
           <a:prstGeom prst="rect">
@@ -21160,7 +21216,7 @@
         </p:nvSpPr>
         <p:spPr>
           <a:xfrm>
-            <a:off x="1463040" y="4160520"/>
+            <a:off x="1463040" y="4058402"/>
             <a:ext cx="54864" cy="640080"/>
           </a:xfrm>
           <a:prstGeom prst="rect">
@@ -21195,7 +21251,7 @@
         </p:blipFill>
         <p:spPr>
           <a:xfrm>
-            <a:off x="1691640" y="4270248"/>
+            <a:off x="1691640" y="4168130"/>
             <a:ext cx="365760" cy="365760"/>
           </a:xfrm>
           <a:prstGeom prst="rect">
@@ -21211,7 +21267,7 @@
         </p:nvSpPr>
         <p:spPr>
           <a:xfrm>
-            <a:off x="2194560" y="4206240"/>
+            <a:off x="2194560" y="4104122"/>
             <a:ext cx="4846320" cy="320040"/>
           </a:xfrm>
           <a:prstGeom prst="rect">
@@ -21250,7 +21306,7 @@
         </p:nvSpPr>
         <p:spPr>
           <a:xfrm>
-            <a:off x="2194560" y="4480560"/>
+            <a:off x="2194560" y="4378442"/>
             <a:ext cx="4846320" cy="274320"/>
           </a:xfrm>
           <a:prstGeom prst="rect">
@@ -21289,7 +21345,7 @@
         </p:nvSpPr>
         <p:spPr>
           <a:xfrm>
-            <a:off x="731520" y="4434840"/>
+            <a:off x="731520" y="4698482"/>
             <a:ext cx="7680960" cy="365760"/>
           </a:xfrm>
           <a:prstGeom prst="rect">
@@ -25130,6 +25186,62 @@
           <a:lstStyle/>
           <a:p>
             <a:endParaRPr lang="en-US"/>
+          </a:p>
+        </p:txBody>
+      </p:sp>
+      <p:sp>
+        <p:nvSpPr>
+          <p:cNvPr id="10" name="Text 3">
+            <a:extLst>
+              <a:ext uri="{FF2B5EF4-FFF2-40B4-BE49-F238E27FC236}">
+                <a16:creationId xmlns:a16="http://schemas.microsoft.com/office/drawing/2014/main" id="{AFDDF638-BE50-036F-C387-2B988896826B}"/>
+              </a:ext>
+            </a:extLst>
+          </p:cNvPr>
+          <p:cNvSpPr/>
+          <p:nvPr/>
+        </p:nvSpPr>
+        <p:spPr>
+          <a:xfrm>
+            <a:off x="675047" y="3200400"/>
+            <a:ext cx="7680960" cy="457200"/>
+          </a:xfrm>
+          <a:prstGeom prst="rect">
+            <a:avLst/>
+          </a:prstGeom>
+          <a:noFill/>
+          <a:ln/>
+        </p:spPr>
+        <p:txBody>
+          <a:bodyPr wrap="square" rtlCol="0" anchor="ctr"/>
+          <a:lstStyle/>
+          <a:p>
+            <a:pPr marL="0" indent="0" algn="ctr">
+              <a:buNone/>
+            </a:pPr>
+            <a:r>
+              <a:rPr lang="en-US" sz="1200" dirty="0">
+                <a:solidFill>
+                  <a:srgbClr val="67E8F9"/>
+                </a:solidFill>
+                <a:latin typeface="Calibri" pitchFamily="34" charset="0"/>
+                <a:ea typeface="Calibri" pitchFamily="34" charset="-122"/>
+                <a:cs typeface="Calibri" pitchFamily="34" charset="-120"/>
+              </a:rPr>
+              <a:t>https://human-</a:t>
+            </a:r>
+            <a:r>
+              <a:rPr lang="en-US" sz="1200" dirty="0" err="1">
+                <a:solidFill>
+                  <a:srgbClr val="67E8F9"/>
+                </a:solidFill>
+                <a:latin typeface="Calibri" pitchFamily="34" charset="0"/>
+                <a:ea typeface="Calibri" pitchFamily="34" charset="-122"/>
+                <a:cs typeface="Calibri" pitchFamily="34" charset="-120"/>
+              </a:rPr>
+              <a:t>blueprint.ai</a:t>
+            </a:r>
+            <a:endParaRPr lang="en-US" sz="1200" dirty="0"/>
           </a:p>
         </p:txBody>
       </p:sp>

</xml_diff>